<commit_message>
Fix privacy concerns (#45)
* Fix privacy concerns

* update readme
</commit_message>
<xml_diff>
--- a/DepGraph.pptx
+++ b/DepGraph.pptx
@@ -13,6 +13,7 @@
     <p:sldId id="261" r:id="rId12"/>
     <p:sldId id="262" r:id="rId13"/>
     <p:sldId id="263" r:id="rId14"/>
+    <p:sldId id="268" r:id="rId19"/>
     <p:sldId id="264" r:id="rId15"/>
     <p:sldId id="265" r:id="rId16"/>
     <p:sldId id="266" r:id="rId17"/>
@@ -4579,7 +4580,7 @@
                 </a:solidFill>
                 <a:latin typeface="Calibri"/>
               </a:rPr>
-              <a:t>Pan, zoom, minimap, focus lens</a:t>
+              <a:t>Pan, zoom, minimap, responsive toolbar</a:t>
             </a:r>
           </a:p>
           <a:p>
@@ -4596,7 +4597,7 @@
                 </a:solidFill>
                 <a:latin typeface="Calibri"/>
               </a:rPr>
-              <a:t>Simulation, story mode, layering rules</a:t>
+              <a:t>Guided tour, timeline, insights, layers architecture</a:t>
             </a:r>
           </a:p>
         </p:txBody>
@@ -5650,6 +5651,661 @@
 </p:sld>
 </file>
 
+<file path=ppt/slides/slide13.xml><?xml version="1.0" encoding="utf-8"?>
+<p:sld xmlns:a="http://schemas.openxmlformats.org/drawingml/2006/main" xmlns:p="http://schemas.openxmlformats.org/presentationml/2006/main">
+  <p:cSld>
+    <p:bg>
+      <p:bgPr>
+        <a:solidFill>
+          <a:srgbClr val="0F172A"/>
+        </a:solidFill>
+        <a:effectLst/>
+      </p:bgPr>
+    </p:bg>
+    <p:spTree>
+      <p:nvGrpSpPr>
+        <p:cNvPr id="1" name=""/>
+        <p:cNvGrpSpPr/>
+        <p:nvPr/>
+      </p:nvGrpSpPr>
+      <p:grpSpPr/>
+      <p:sp>
+        <p:nvSpPr>
+          <p:cNvPr id="2" name="TextBox 1"/>
+          <p:cNvSpPr txBox="1"/>
+          <p:nvPr/>
+        </p:nvSpPr>
+        <p:spPr>
+          <a:xfrm>
+            <a:off x="640080" y="320040"/>
+            <a:ext cx="7315200" cy="502920"/>
+          </a:xfrm>
+          <a:prstGeom prst="rect">
+            <a:avLst/>
+          </a:prstGeom>
+          <a:noFill/>
+        </p:spPr>
+        <p:txBody>
+          <a:bodyPr wrap="square"/>
+          <a:lstStyle/>
+          <a:p>
+            <a:pPr algn="l">
+              <a:defRPr sz="3200" b="1">
+                <a:solidFill>
+                  <a:srgbClr val="F8FAFC"/>
+                </a:solidFill>
+                <a:latin typeface="Calibri"/>
+              </a:defRPr>
+            </a:pPr>
+            <a:r>
+              <a:t>Layers Architecture View</a:t>
+            </a:r>
+          </a:p>
+        </p:txBody>
+      </p:sp>
+      <p:sp>
+        <p:nvSpPr>
+          <p:cNvPr id="3" name="TextBox 2"/>
+          <p:cNvSpPr txBox="1"/>
+          <p:nvPr/>
+        </p:nvSpPr>
+        <p:spPr>
+          <a:xfrm>
+            <a:off x="640080" y="822960"/>
+            <a:ext cx="7315200" cy="320040"/>
+          </a:xfrm>
+          <a:prstGeom prst="rect">
+            <a:avLst/>
+          </a:prstGeom>
+          <a:noFill/>
+        </p:spPr>
+        <p:txBody>
+          <a:bodyPr wrap="square"/>
+          <a:lstStyle/>
+          <a:p>
+            <a:pPr algn="l">
+              <a:defRPr sz="1100" b="0">
+                <a:solidFill>
+                  <a:srgbClr val="06B6D4"/>
+                </a:solidFill>
+                <a:latin typeface="Calibri"/>
+              </a:defRPr>
+            </a:pPr>
+            <a:r>
+              <a:t>SWIM-LANE LAYOUT + VIOLATION DETECTION + DRAG SIMULATION</a:t>
+            </a:r>
+          </a:p>
+        </p:txBody>
+      </p:sp>
+      <p:sp>
+        <p:nvSpPr>
+          <p:cNvPr id="4" name="Rounded Rectangle 3"/>
+          <p:cNvSpPr/>
+          <p:nvPr/>
+        </p:nvSpPr>
+        <p:spPr>
+          <a:xfrm>
+            <a:off x="640080" y="1325880"/>
+            <a:ext cx="4389120" cy="3520440"/>
+          </a:xfrm>
+          <a:prstGeom prst="roundRect">
+            <a:avLst/>
+          </a:prstGeom>
+          <a:solidFill>
+            <a:srgbClr val="0B0E17"/>
+          </a:solidFill>
+          <a:ln>
+            <a:noFill/>
+          </a:ln>
+        </p:spPr>
+        <p:style>
+          <a:lnRef idx="1">
+            <a:schemeClr val="accent1"/>
+          </a:lnRef>
+          <a:fillRef idx="3">
+            <a:schemeClr val="accent1"/>
+          </a:fillRef>
+          <a:effectRef idx="2">
+            <a:schemeClr val="accent1"/>
+          </a:effectRef>
+          <a:fontRef idx="minor">
+            <a:schemeClr val="lt1"/>
+          </a:fontRef>
+        </p:style>
+        <p:txBody>
+          <a:bodyPr rtlCol="0" anchor="ctr"/>
+          <a:lstStyle/>
+          <a:p>
+            <a:pPr algn="ctr"/>
+          </a:p>
+        </p:txBody>
+      </p:sp>
+      <p:sp>
+        <p:nvSpPr>
+          <p:cNvPr id="5" name="TextBox 4"/>
+          <p:cNvSpPr txBox="1"/>
+          <p:nvPr/>
+        </p:nvSpPr>
+        <p:spPr>
+          <a:xfrm>
+            <a:off x="777240" y="1435608"/>
+            <a:ext cx="4114800" cy="3300984"/>
+          </a:xfrm>
+          <a:prstGeom prst="rect">
+            <a:avLst/>
+          </a:prstGeom>
+          <a:noFill/>
+        </p:spPr>
+        <p:txBody>
+          <a:bodyPr wrap="square">
+            <a:spAutoFit/>
+          </a:bodyPr>
+          <a:lstStyle/>
+          <a:p>
+            <a:pPr>
+              <a:spcAft>
+                <a:spcPts val="100"/>
+              </a:spcAft>
+            </a:pPr>
+            <a:r>
+              <a:rPr sz="850">
+                <a:solidFill>
+                  <a:srgbClr val="A5F3FC"/>
+                </a:solidFill>
+                <a:latin typeface="Consolas"/>
+              </a:rPr>
+              <a:t>// Define custom architecture layers:</a:t>
+            </a:r>
+          </a:p>
+          <a:p>
+            <a:pPr>
+              <a:spcAft>
+                <a:spcPts val="100"/>
+              </a:spcAft>
+            </a:pPr>
+            <a:r>
+              <a:rPr sz="850">
+                <a:solidFill>
+                  <a:srgbClr val="A5F3FC"/>
+                </a:solidFill>
+                <a:latin typeface="Consolas"/>
+              </a:rPr>
+              <a:t xml:space="preserve">ui, service, data, util</a:t>
+            </a:r>
+          </a:p>
+          <a:p>
+            <a:pPr>
+              <a:spcAft>
+                <a:spcPts val="100"/>
+              </a:spcAft>
+            </a:pPr>
+            <a:r>
+              <a:rPr sz="850">
+                <a:solidFill>
+                  <a:srgbClr val="A5F3FC"/>
+                </a:solidFill>
+                <a:latin typeface="Consolas"/>
+              </a:rPr>
+              <a:t xml:space="preserve">
+// Auto-detection by dependency depth:</a:t>
+            </a:r>
+          </a:p>
+          <a:p>
+            <a:pPr>
+              <a:spcAft>
+                <a:spcPts val="100"/>
+              </a:spcAft>
+            </a:pPr>
+            <a:r>
+              <a:rPr sz="850">
+                <a:solidFill>
+                  <a:srgbClr val="A5F3FC"/>
+                </a:solidFill>
+                <a:latin typeface="Consolas"/>
+              </a:rPr>
+              <a:t xml:space="preserve">L0  Entry points (app.js, main.py)</a:t>
+            </a:r>
+          </a:p>
+          <a:p>
+            <a:pPr>
+              <a:spcAft>
+                <a:spcPts val="100"/>
+              </a:spcAft>
+            </a:pPr>
+            <a:r>
+              <a:rPr sz="850">
+                <a:solidFill>
+                  <a:srgbClr val="A5F3FC"/>
+                </a:solidFill>
+                <a:latin typeface="Consolas"/>
+              </a:rPr>
+              <a:t xml:space="preserve">L1  Service modules</a:t>
+            </a:r>
+          </a:p>
+          <a:p>
+            <a:pPr>
+              <a:spcAft>
+                <a:spcPts val="100"/>
+              </a:spcAft>
+            </a:pPr>
+            <a:r>
+              <a:rPr sz="850">
+                <a:solidFill>
+                  <a:srgbClr val="A5F3FC"/>
+                </a:solidFill>
+                <a:latin typeface="Consolas"/>
+              </a:rPr>
+              <a:t xml:space="preserve">L2  Data access / utilities</a:t>
+            </a:r>
+          </a:p>
+          <a:p>
+            <a:pPr>
+              <a:spcAft>
+                <a:spcPts val="100"/>
+              </a:spcAft>
+            </a:pPr>
+            <a:r>
+              <a:rPr sz="850">
+                <a:solidFill>
+                  <a:srgbClr val="A5F3FC"/>
+                </a:solidFill>
+                <a:latin typeface="Consolas"/>
+              </a:rPr>
+              <a:t xml:space="preserve">L3  Shared helpers</a:t>
+            </a:r>
+          </a:p>
+          <a:p>
+            <a:pPr>
+              <a:spcAft>
+                <a:spcPts val="100"/>
+              </a:spcAft>
+            </a:pPr>
+            <a:r>
+              <a:rPr sz="850">
+                <a:solidFill>
+                  <a:srgbClr val="A5F3FC"/>
+                </a:solidFill>
+                <a:latin typeface="Consolas"/>
+              </a:rPr>
+              <a:t xml:space="preserve">
+// Violations: deeper -&gt; shallower</a:t>
+            </a:r>
+          </a:p>
+          <a:p>
+            <a:pPr>
+              <a:spcAft>
+                <a:spcPts val="100"/>
+              </a:spcAft>
+            </a:pPr>
+            <a:r>
+              <a:rPr sz="850">
+                <a:solidFill>
+                  <a:srgbClr val="A5F3FC"/>
+                </a:solidFill>
+                <a:latin typeface="Consolas"/>
+              </a:rPr>
+              <a:t xml:space="preserve">data/db.js -&gt; ui/App.jsx     VIOLATION</a:t>
+            </a:r>
+          </a:p>
+          <a:p>
+            <a:pPr>
+              <a:spcAft>
+                <a:spcPts val="100"/>
+              </a:spcAft>
+            </a:pPr>
+            <a:r>
+              <a:rPr sz="850">
+                <a:solidFill>
+                  <a:srgbClr val="A5F3FC"/>
+                </a:solidFill>
+                <a:latin typeface="Consolas"/>
+              </a:rPr>
+              <a:t xml:space="preserve">util/log.js -&gt; service/auth.js  VIOLATION</a:t>
+            </a:r>
+          </a:p>
+        </p:txBody>
+      </p:sp>
+      <p:sp>
+        <p:nvSpPr>
+          <p:cNvPr id="6" name="Rectangle 5"/>
+          <p:cNvSpPr/>
+          <p:nvPr/>
+        </p:nvSpPr>
+        <p:spPr>
+          <a:xfrm>
+            <a:off x="5257800" y="1417320"/>
+            <a:ext cx="73152" cy="914400"/>
+          </a:xfrm>
+          <a:prstGeom prst="rect">
+            <a:avLst/>
+          </a:prstGeom>
+          <a:solidFill>
+            <a:srgbClr val="06B6D4"/>
+          </a:solidFill>
+          <a:ln>
+            <a:noFill/>
+          </a:ln>
+        </p:spPr>
+        <p:style>
+          <a:lnRef idx="1">
+            <a:schemeClr val="accent1"/>
+          </a:lnRef>
+          <a:fillRef idx="3">
+            <a:schemeClr val="accent1"/>
+          </a:fillRef>
+          <a:effectRef idx="2">
+            <a:schemeClr val="accent1"/>
+          </a:effectRef>
+          <a:fontRef idx="minor">
+            <a:schemeClr val="lt1"/>
+          </a:fontRef>
+        </p:style>
+        <p:txBody>
+          <a:bodyPr rtlCol="0" anchor="ctr"/>
+          <a:lstStyle/>
+          <a:p>
+            <a:pPr algn="ctr"/>
+          </a:p>
+        </p:txBody>
+      </p:sp>
+      <p:sp>
+        <p:nvSpPr>
+          <p:cNvPr id="7" name="TextBox 6"/>
+          <p:cNvSpPr txBox="1"/>
+          <p:nvPr/>
+        </p:nvSpPr>
+        <p:spPr>
+          <a:xfrm>
+            <a:off x="5486400" y="1435608"/>
+            <a:ext cx="3200400" cy="274320"/>
+          </a:xfrm>
+          <a:prstGeom prst="rect">
+            <a:avLst/>
+          </a:prstGeom>
+          <a:noFill/>
+        </p:spPr>
+        <p:txBody>
+          <a:bodyPr wrap="square"/>
+          <a:lstStyle/>
+          <a:p>
+            <a:pPr algn="l">
+              <a:defRPr sz="1300" b="1">
+                <a:solidFill>
+                  <a:srgbClr val="F8FAFC"/>
+                </a:solidFill>
+                <a:latin typeface="Calibri"/>
+              </a:defRPr>
+            </a:pPr>
+            <a:r>
+              <a:t>Swim-Lane Layout</a:t>
+            </a:r>
+          </a:p>
+        </p:txBody>
+      </p:sp>
+      <p:sp>
+        <p:nvSpPr>
+          <p:cNvPr id="8" name="TextBox 7"/>
+          <p:cNvSpPr txBox="1"/>
+          <p:nvPr/>
+        </p:nvSpPr>
+        <p:spPr>
+          <a:xfrm>
+            <a:off x="5486400" y="1755648"/>
+            <a:ext cx="3200400" cy="594360"/>
+          </a:xfrm>
+          <a:prstGeom prst="rect">
+            <a:avLst/>
+          </a:prstGeom>
+          <a:noFill/>
+        </p:spPr>
+        <p:txBody>
+          <a:bodyPr wrap="square"/>
+          <a:lstStyle/>
+          <a:p>
+            <a:pPr algn="l">
+              <a:defRPr sz="1050" b="0">
+                <a:solidFill>
+                  <a:srgbClr val="BDC5D0"/>
+                </a:solidFill>
+                <a:latin typeface="Calibri"/>
+              </a:defRPr>
+            </a:pPr>
+            <a:r>
+              <a:t>Nodes arranged in horizontal layers by dependency depth. Barycenter heuristic minimizes edge crossings. Directory clustering keeps related files together.</a:t>
+            </a:r>
+          </a:p>
+        </p:txBody>
+      </p:sp>
+      <p:sp>
+        <p:nvSpPr>
+          <p:cNvPr id="9" name="Rectangle 8"/>
+          <p:cNvSpPr/>
+          <p:nvPr/>
+        </p:nvSpPr>
+        <p:spPr>
+          <a:xfrm>
+            <a:off x="5257800" y="2606040"/>
+            <a:ext cx="73152" cy="914400"/>
+          </a:xfrm>
+          <a:prstGeom prst="rect">
+            <a:avLst/>
+          </a:prstGeom>
+          <a:solidFill>
+            <a:srgbClr val="8B5CF6"/>
+          </a:solidFill>
+          <a:ln>
+            <a:noFill/>
+          </a:ln>
+        </p:spPr>
+        <p:style>
+          <a:lnRef idx="1">
+            <a:schemeClr val="accent1"/>
+          </a:lnRef>
+          <a:fillRef idx="3">
+            <a:schemeClr val="accent1"/>
+          </a:fillRef>
+          <a:effectRef idx="2">
+            <a:schemeClr val="accent1"/>
+          </a:effectRef>
+          <a:fontRef idx="minor">
+            <a:schemeClr val="lt1"/>
+          </a:fontRef>
+        </p:style>
+        <p:txBody>
+          <a:bodyPr rtlCol="0" anchor="ctr"/>
+          <a:lstStyle/>
+          <a:p>
+            <a:pPr algn="ctr"/>
+          </a:p>
+        </p:txBody>
+      </p:sp>
+      <p:sp>
+        <p:nvSpPr>
+          <p:cNvPr id="10" name="TextBox 9"/>
+          <p:cNvSpPr txBox="1"/>
+          <p:nvPr/>
+        </p:nvSpPr>
+        <p:spPr>
+          <a:xfrm>
+            <a:off x="5486400" y="2624328"/>
+            <a:ext cx="3200400" cy="274320"/>
+          </a:xfrm>
+          <a:prstGeom prst="rect">
+            <a:avLst/>
+          </a:prstGeom>
+          <a:noFill/>
+        </p:spPr>
+        <p:txBody>
+          <a:bodyPr wrap="square"/>
+          <a:lstStyle/>
+          <a:p>
+            <a:pPr algn="l">
+              <a:defRPr sz="1300" b="1">
+                <a:solidFill>
+                  <a:srgbClr val="F8FAFC"/>
+                </a:solidFill>
+                <a:latin typeface="Calibri"/>
+              </a:defRPr>
+            </a:pPr>
+            <a:r>
+              <a:t>Violation Detection</a:t>
+            </a:r>
+          </a:p>
+        </p:txBody>
+      </p:sp>
+      <p:sp>
+        <p:nvSpPr>
+          <p:cNvPr id="11" name="TextBox 10"/>
+          <p:cNvSpPr txBox="1"/>
+          <p:nvPr/>
+        </p:nvSpPr>
+        <p:spPr>
+          <a:xfrm>
+            <a:off x="5486400" y="2944368"/>
+            <a:ext cx="3200400" cy="594360"/>
+          </a:xfrm>
+          <a:prstGeom prst="rect">
+            <a:avLst/>
+          </a:prstGeom>
+          <a:noFill/>
+        </p:spPr>
+        <p:txBody>
+          <a:bodyPr wrap="square"/>
+          <a:lstStyle/>
+          <a:p>
+            <a:pPr algn="l">
+              <a:defRPr sz="1050" b="0">
+                <a:solidFill>
+                  <a:srgbClr val="BDC5D0"/>
+                </a:solidFill>
+                <a:latin typeface="Calibri"/>
+              </a:defRPr>
+            </a:pPr>
+            <a:r>
+              <a:t>Imports pointing upward (deeper file importing shallower) are flagged with pulsing amber dashed edges. Worst offenders shown in sidebar.</a:t>
+            </a:r>
+          </a:p>
+        </p:txBody>
+      </p:sp>
+      <p:sp>
+        <p:nvSpPr>
+          <p:cNvPr id="12" name="Rectangle 11"/>
+          <p:cNvSpPr/>
+          <p:nvPr/>
+        </p:nvSpPr>
+        <p:spPr>
+          <a:xfrm>
+            <a:off x="5257800" y="3794760"/>
+            <a:ext cx="73152" cy="914400"/>
+          </a:xfrm>
+          <a:prstGeom prst="rect">
+            <a:avLst/>
+          </a:prstGeom>
+          <a:solidFill>
+            <a:srgbClr val="10B981"/>
+          </a:solidFill>
+          <a:ln>
+            <a:noFill/>
+          </a:ln>
+        </p:spPr>
+        <p:style>
+          <a:lnRef idx="1">
+            <a:schemeClr val="accent1"/>
+          </a:lnRef>
+          <a:fillRef idx="3">
+            <a:schemeClr val="accent1"/>
+          </a:fillRef>
+          <a:effectRef idx="2">
+            <a:schemeClr val="accent1"/>
+          </a:effectRef>
+          <a:fontRef idx="minor">
+            <a:schemeClr val="lt1"/>
+          </a:fontRef>
+        </p:style>
+        <p:txBody>
+          <a:bodyPr rtlCol="0" anchor="ctr"/>
+          <a:lstStyle/>
+          <a:p>
+            <a:pPr algn="ctr"/>
+          </a:p>
+        </p:txBody>
+      </p:sp>
+      <p:sp>
+        <p:nvSpPr>
+          <p:cNvPr id="13" name="TextBox 12"/>
+          <p:cNvSpPr txBox="1"/>
+          <p:nvPr/>
+        </p:nvSpPr>
+        <p:spPr>
+          <a:xfrm>
+            <a:off x="5486400" y="3813048"/>
+            <a:ext cx="3200400" cy="274320"/>
+          </a:xfrm>
+          <a:prstGeom prst="rect">
+            <a:avLst/>
+          </a:prstGeom>
+          <a:noFill/>
+        </p:spPr>
+        <p:txBody>
+          <a:bodyPr wrap="square"/>
+          <a:lstStyle/>
+          <a:p>
+            <a:pPr algn="l">
+              <a:defRPr sz="1300" b="1">
+                <a:solidFill>
+                  <a:srgbClr val="F8FAFC"/>
+                </a:solidFill>
+                <a:latin typeface="Calibri"/>
+              </a:defRPr>
+            </a:pPr>
+            <a:r>
+              <a:t>Drag-to-Reassign</a:t>
+            </a:r>
+          </a:p>
+        </p:txBody>
+      </p:sp>
+      <p:sp>
+        <p:nvSpPr>
+          <p:cNvPr id="14" name="TextBox 13"/>
+          <p:cNvSpPr txBox="1"/>
+          <p:nvPr/>
+        </p:nvSpPr>
+        <p:spPr>
+          <a:xfrm>
+            <a:off x="5486400" y="4133088"/>
+            <a:ext cx="3200400" cy="594360"/>
+          </a:xfrm>
+          <a:prstGeom prst="rect">
+            <a:avLst/>
+          </a:prstGeom>
+          <a:noFill/>
+        </p:spPr>
+        <p:txBody>
+          <a:bodyPr wrap="square"/>
+          <a:lstStyle/>
+          <a:p>
+            <a:pPr algn="l">
+              <a:defRPr sz="1050" b="0">
+                <a:solidFill>
+                  <a:srgbClr val="BDC5D0"/>
+                </a:solidFill>
+                <a:latin typeface="Calibri"/>
+              </a:defRPr>
+            </a:pPr>
+            <a:r>
+              <a:t>Drag nodes between layers to simulate architectural changes. Per-file overrides with instant re-layout and violation recalculation.</a:t>
+            </a:r>
+          </a:p>
+        </p:txBody>
+      </p:sp>
+    </p:spTree>
+  </p:cSld>
+  <p:clrMapOvr>
+    <a:masterClrMapping/>
+  </p:clrMapOvr>
+</p:sld>
+</file>
+
 <file path=ppt/slides/slide2.xml><?xml version="1.0" encoding="utf-8"?>
 <p:sld xmlns:a="http://schemas.openxmlformats.org/drawingml/2006/main" xmlns:p="http://schemas.openxmlformats.org/presentationml/2006/main" xmlns:r="http://schemas.openxmlformats.org/officeDocument/2006/relationships">
   <p:cSld>
@@ -6398,7 +7054,7 @@
               </a:defRPr>
             </a:pPr>
             <a:r>
-              <a:t>Two Powerful Views</a:t>
+              <a:t>Three Powerful Views</a:t>
             </a:r>
           </a:p>
         </p:txBody>
@@ -6432,7 +7088,7 @@
               </a:defRPr>
             </a:pPr>
             <a:r>
-              <a:t>Interactive force-directed graph and dependency tree explorer</a:t>
+              <a:t>Graph, dependency tree, and layered architecture explorer</a:t>
             </a:r>
           </a:p>
         </p:txBody>
@@ -7098,7 +7754,7 @@
               </a:defRPr>
             </a:pPr>
             <a:r>
-              <a:t>Sidebar views, blast radius, cycle detection from your editor</a:t>
+              <a:t>Graph, tree, and layers views with full analysis from your editor</a:t>
             </a:r>
           </a:p>
         </p:txBody>
@@ -7209,7 +7865,7 @@
               </a:defRPr>
             </a:pPr>
             <a:r>
-              <a:t>Simulation, merge/split, story mode, layering rules</a:t>
+              <a:t>Simulation, merge/split, story mode, guided tour, timeline</a:t>
             </a:r>
           </a:p>
         </p:txBody>
@@ -7736,7 +8392,7 @@
               </a:defRPr>
             </a:pPr>
             <a:r>
-              <a:t>index.html + 13 JS modules + style.css</a:t>
+              <a:t>index.html + 14 JS modules + style.css</a:t>
             </a:r>
           </a:p>
         </p:txBody>
@@ -7776,7 +8432,7 @@
                 </a:solidFill>
                 <a:latin typeface="Calibri"/>
               </a:rPr>
-              <a:t>13-module SPA with floating UI panels</a:t>
+              <a:t>14-module SPA with floating UI panels</a:t>
             </a:r>
           </a:p>
           <a:p>
@@ -7793,7 +8449,7 @@
                 </a:solidFill>
                 <a:latin typeface="Calibri"/>
               </a:rPr>
-              <a:t>Two views: graph and tree</a:t>
+              <a:t>Three views: graph, tree, and layers</a:t>
             </a:r>
           </a:p>
           <a:p>
@@ -11619,7 +12275,7 @@
               </a:defRPr>
             </a:pPr>
             <a:r>
-              <a:t>CYTOSCAPE.JS + FORCE LAYOUT + TWO VIEWS</a:t>
+              <a:t>CYTOSCAPE.JS + FORCE LAYOUT + THREE VIEWS</a:t>
             </a:r>
           </a:p>
         </p:txBody>
@@ -12180,7 +12836,7 @@
               </a:defRPr>
             </a:pPr>
             <a:r>
-              <a:t>Battle-tested graph library. Two views: interactive graph and dependency tree.</a:t>
+              <a:t>Battle-tested graph library. Three views: graph, dependency tree, and layered architecture.</a:t>
             </a:r>
           </a:p>
         </p:txBody>
@@ -12368,7 +13024,7 @@
               </a:defRPr>
             </a:pPr>
             <a:r>
-              <a:t>13-Module SPA</a:t>
+              <a:t>14-Module SPA</a:t>
             </a:r>
           </a:p>
         </p:txBody>
@@ -12402,7 +13058,7 @@
               </a:defRPr>
             </a:pPr>
             <a:r>
-              <a:t>graph-core, views, ui, tools, analysis, exports, query, simulation, story, state, tour, timeline, app. CDN: Cytoscape, dagre, Prism.js, Inter font.</a:t>
+              <a:t>graph-core, views, ui, tools, analysis, exports, query, simulation, story, state, tour, timeline, layers, app. CDN: Cytoscape, dagre, Prism.js, Inter font.</a:t>
             </a:r>
           </a:p>
         </p:txBody>

</xml_diff>